<commit_message>
Restyle commercial enterprises deck in economics theme
Co-Authored-By: Claude Opus 5.5 <noreply@anthropic.com>
Claude-Session: https://claude.ai/code/session_019XwRdqvMoKnJvFiroXySfz
</commit_message>
<xml_diff>
--- a/vidy_predpriyatiy/Виды_коммерческих_предприятий_РФ.pptx
+++ b/vidy_predpriyatiy/Виды_коммерческих_предприятий_РФ.pptx
@@ -114,12 +114,12 @@
   <p:extLst>
     <p:ext uri="{521415D9-36F7-43E2-AB2F-B90AF26B5E84}">
       <p14:sectionLst xmlns:p14="http://schemas.microsoft.com/office/powerpoint/2010/main">
-        <p14:section name="Введение" id="{6b01c0d6-2cb6-9e3a-7e2e-669df636e282}">
+        <p14:section name="Введение" id="{155c2cfe-b0db-44b2-3834-27835e6bc2e1}">
           <p14:sldIdLst>
             <p14:sldId id="256"/>
           </p14:sldIdLst>
         </p14:section>
-        <p14:section name="Формы" id="{d97b599a-8346-dabc-2798-c6fe4f7228fe}">
+        <p14:section name="Формы" id="{2f373173-3629-6b27-fe1c-bf88cc29fdee}">
           <p14:sldIdLst>
             <p14:sldId id="257"/>
             <p14:sldId id="258"/>
@@ -129,7 +129,7 @@
             <p14:sldId id="262"/>
           </p14:sldIdLst>
         </p14:section>
-        <p14:section name="Итоги" id="{4f3a0680-52ad-13ca-41aa-6e3fe2699923}">
+        <p14:section name="Итоги" id="{b66a0d78-bb96-d381-6917-58f9dcb6e4a6}">
           <p14:sldIdLst>
             <p14:sldId id="263"/>
           </p14:sldIdLst>
@@ -1256,7 +1256,7 @@
     <p:bg>
       <p:bgPr>
         <a:solidFill>
-          <a:schemeClr val="bg1"/>
+          <a:schemeClr val="tx1"/>
         </a:solidFill>
       </p:bgPr>
     </p:bg>
@@ -1287,9 +1287,16 @@
   <p:cSld name="CONTENT">
     <p:bg>
       <p:bgPr>
-        <a:solidFill>
-          <a:schemeClr val="bg1"/>
-        </a:solidFill>
+        <a:blipFill dpi="0" rotWithShape="1">
+          <a:blip r:embed="rId1">
+            <a:lum/>
+          </a:blip>
+          <a:srcRect/>
+          <a:stretch>
+            <a:fillRect/>
+          </a:stretch>
+        </a:blipFill>
+        <a:effectLst/>
       </p:bgPr>
     </p:bg>
     <p:spTree>
@@ -1334,9 +1341,9 @@
                 <a:solidFill>
                   <a:schemeClr val="tx1"/>
                 </a:solidFill>
-                <a:latin typeface="Cambria" pitchFamily="34" charset="0"/>
-                <a:ea typeface="Cambria" pitchFamily="34" charset="-122"/>
-                <a:cs typeface="Cambria" pitchFamily="34" charset="-120"/>
+                <a:latin typeface="Georgia" pitchFamily="34" charset="0"/>
+                <a:ea typeface="Georgia" pitchFamily="34" charset="-122"/>
+                <a:cs typeface="Georgia" pitchFamily="34" charset="-120"/>
               </a:defRPr>
             </a:lvl1pPr>
           </a:lstStyle>
@@ -1378,7 +1385,7 @@
                   <a:schemeClr val="tx2"/>
                 </a:solidFill>
               </a:rPr>
-              <a:t>Виды коммерческих предприятий в РФ</a:t>
+              <a:t>ЭКОНОМИКА  ·  Виды коммерческих предприятий в РФ</a:t>
             </a:r>
             <a:endParaRPr lang="en-US" sz="1100" dirty="0"/>
           </a:p>
@@ -1780,7 +1787,7 @@
       </p:grpSpPr>
       <p:pic>
         <p:nvPicPr>
-          <p:cNvPr id="3" name="a_03_hero" descr="/tmp/claude-0/-home-user-musor/c6980a0f-2a52-569f-a1fc-691d09a5d10f/scratchpad/biz/hero.png">    </p:cNvPr>
+          <p:cNvPr id="3" name="a_03_hero" descr="/tmp/claude-0/-home-user-musor/c6980a0f-2a52-569f-a1fc-691d09a5d10f/scratchpad/biz/hero2.png">    </p:cNvPr>
           <p:cNvPicPr>
             <a:picLocks noChangeAspect="1"/>
           </p:cNvPicPr>
@@ -1794,7 +1801,7 @@
         </p:blipFill>
         <p:spPr>
           <a:xfrm>
-            <a:off x="6400800" y="914400"/>
+            <a:off x="6400800" y="960120"/>
             <a:ext cx="5303520" cy="4864608"/>
           </a:xfrm>
           <a:prstGeom prst="rect">
@@ -1811,7 +1818,7 @@
         <p:spPr>
           <a:xfrm>
             <a:off x="685800" y="1371600"/>
-            <a:ext cx="5486400" cy="320040"/>
+            <a:ext cx="5669280" cy="320040"/>
           </a:xfrm>
           <a:prstGeom prst="rect">
             <a:avLst/>
@@ -1827,14 +1834,14 @@
               <a:buNone/>
             </a:pPr>
             <a:r>
-              <a:rPr lang="ru-RU" sz="1400" b="1" spc="300" kern="0" dirty="0">
+              <a:rPr lang="ru-RU" sz="1300" b="1" spc="300" kern="0" dirty="0">
                 <a:solidFill>
-                  <a:schemeClr val="accent1"/>
+                  <a:schemeClr val="accent3"/>
                 </a:solidFill>
               </a:rPr>
-              <a:t>ДОКЛАД  ·  ЭКОНОМИКА И ПРАВО</a:t>
+              <a:t>ЭКОНОМИКА  ·  ФОРМЫ БИЗНЕСА</a:t>
             </a:r>
-            <a:endParaRPr lang="ru-RU" sz="1400" dirty="0"/>
+            <a:endParaRPr lang="ru-RU" sz="1300" dirty="0"/>
           </a:p>
         </p:txBody>
       </p:sp>
@@ -1865,11 +1872,11 @@
             <a:r>
               <a:rPr lang="ru-RU" sz="4000" b="1" dirty="0">
                 <a:solidFill>
-                  <a:schemeClr val="tx1"/>
+                  <a:schemeClr val="bg1"/>
                 </a:solidFill>
-                <a:latin typeface="Cambria" pitchFamily="34" charset="0"/>
-                <a:ea typeface="Cambria" pitchFamily="34" charset="-122"/>
-                <a:cs typeface="Cambria" pitchFamily="34" charset="-120"/>
+                <a:latin typeface="Georgia" pitchFamily="34" charset="0"/>
+                <a:ea typeface="Georgia" pitchFamily="34" charset="-122"/>
+                <a:cs typeface="Georgia" pitchFamily="34" charset="-120"/>
               </a:rPr>
               <a:t>Виды коммерческих предприятий в РФ</a:t>
             </a:r>
@@ -1904,7 +1911,7 @@
             <a:r>
               <a:rPr lang="ru-RU" sz="1900" dirty="0">
                 <a:solidFill>
-                  <a:schemeClr val="tx2"/>
+                  <a:schemeClr val="accent6"/>
                 </a:solidFill>
               </a:rPr>
               <a:t>ООО, АО, товарищества, кооперативы и унитарные предприятия: кто владеет и кто отвечает</a:t>
@@ -1940,7 +1947,7 @@
             <a:r>
               <a:rPr lang="ru-RU" sz="1400" dirty="0">
                 <a:solidFill>
-                  <a:schemeClr val="tx2"/>
+                  <a:schemeClr val="accent6"/>
                 </a:solidFill>
               </a:rPr>
               <a:t>Егор  ·  Света  ·  2026</a:t>
@@ -2542,9 +2549,9 @@
                 <a:solidFill>
                   <a:schemeClr val="tx1"/>
                 </a:solidFill>
-                <a:latin typeface="Cambria" pitchFamily="34" charset="0"/>
-                <a:ea typeface="Cambria" pitchFamily="34" charset="-122"/>
-                <a:cs typeface="Cambria" pitchFamily="34" charset="-120"/>
+                <a:latin typeface="Georgia" pitchFamily="34" charset="0"/>
+                <a:ea typeface="Georgia" pitchFamily="34" charset="-122"/>
+                <a:cs typeface="Georgia" pitchFamily="34" charset="-120"/>
               </a:rPr>
               <a:t>Что такое коммерческая организация</a:t>
             </a:r>
@@ -3146,7 +3153,7 @@
                   <a:schemeClr val="tx1"/>
                 </a:solidFill>
               </a:rPr>
-              <a:t>Производственные кооперативы</a:t>
+              <a:t>Кооперативы</a:t>
             </a:r>
             <a:endParaRPr lang="ru-RU" sz="1400" dirty="0"/>
           </a:p>
@@ -7646,9 +7653,9 @@
                 <a:solidFill>
                   <a:schemeClr val="tx1"/>
                 </a:solidFill>
-                <a:latin typeface="Cambria" pitchFamily="34" charset="0"/>
-                <a:ea typeface="Cambria" pitchFamily="34" charset="-122"/>
-                <a:cs typeface="Cambria" pitchFamily="34" charset="-120"/>
+                <a:latin typeface="Georgia" pitchFamily="34" charset="0"/>
+                <a:ea typeface="Georgia" pitchFamily="34" charset="-122"/>
+                <a:cs typeface="Georgia" pitchFamily="34" charset="-120"/>
               </a:rPr>
               <a:t>ООО — самая популярная форма бизнеса</a:t>
             </a:r>
@@ -7761,9 +7768,9 @@
                 <a:solidFill>
                   <a:schemeClr val="tx1"/>
                 </a:solidFill>
-                <a:latin typeface="Cambria" pitchFamily="34" charset="0"/>
-                <a:ea typeface="Cambria" pitchFamily="34" charset="-122"/>
-                <a:cs typeface="Cambria" pitchFamily="34" charset="-120"/>
+                <a:latin typeface="Georgia" pitchFamily="34" charset="0"/>
+                <a:ea typeface="Georgia" pitchFamily="34" charset="-122"/>
+                <a:cs typeface="Georgia" pitchFamily="34" charset="-120"/>
               </a:rPr>
               <a:t>1–50</a:t>
             </a:r>
@@ -7912,9 +7919,9 @@
                 <a:solidFill>
                   <a:schemeClr val="tx1"/>
                 </a:solidFill>
-                <a:latin typeface="Cambria" pitchFamily="34" charset="0"/>
-                <a:ea typeface="Cambria" pitchFamily="34" charset="-122"/>
-                <a:cs typeface="Cambria" pitchFamily="34" charset="-120"/>
+                <a:latin typeface="Georgia" pitchFamily="34" charset="0"/>
+                <a:ea typeface="Georgia" pitchFamily="34" charset="-122"/>
+                <a:cs typeface="Georgia" pitchFamily="34" charset="-120"/>
               </a:rPr>
               <a:t>10 000 ₽</a:t>
             </a:r>
@@ -8063,9 +8070,9 @@
                 <a:solidFill>
                   <a:schemeClr val="tx1"/>
                 </a:solidFill>
-                <a:latin typeface="Cambria" pitchFamily="34" charset="0"/>
-                <a:ea typeface="Cambria" pitchFamily="34" charset="-122"/>
-                <a:cs typeface="Cambria" pitchFamily="34" charset="-120"/>
+                <a:latin typeface="Georgia" pitchFamily="34" charset="0"/>
+                <a:ea typeface="Georgia" pitchFamily="34" charset="-122"/>
+                <a:cs typeface="Georgia" pitchFamily="34" charset="-120"/>
               </a:rPr>
               <a:t>Доля</a:t>
             </a:r>
@@ -11584,9 +11591,9 @@
                 <a:solidFill>
                   <a:schemeClr val="tx1"/>
                 </a:solidFill>
-                <a:latin typeface="Cambria" pitchFamily="34" charset="0"/>
-                <a:ea typeface="Cambria" pitchFamily="34" charset="-122"/>
-                <a:cs typeface="Cambria" pitchFamily="34" charset="-120"/>
+                <a:latin typeface="Georgia" pitchFamily="34" charset="0"/>
+                <a:ea typeface="Georgia" pitchFamily="34" charset="-122"/>
+                <a:cs typeface="Georgia" pitchFamily="34" charset="-120"/>
               </a:rPr>
               <a:t>Акционерные общества: ПАО и АО</a:t>
             </a:r>
@@ -11650,9 +11657,9 @@
                 <a:solidFill>
                   <a:schemeClr val="accent2"/>
                 </a:solidFill>
-                <a:latin typeface="Cambria" pitchFamily="34" charset="0"/>
-                <a:ea typeface="Cambria" pitchFamily="34" charset="-122"/>
-                <a:cs typeface="Cambria" pitchFamily="34" charset="-120"/>
+                <a:latin typeface="Georgia" pitchFamily="34" charset="0"/>
+                <a:ea typeface="Georgia" pitchFamily="34" charset="-122"/>
+                <a:cs typeface="Georgia" pitchFamily="34" charset="-120"/>
               </a:rPr>
               <a:t>ПАО</a:t>
             </a:r>
@@ -12007,9 +12014,9 @@
                 <a:solidFill>
                   <a:schemeClr val="accent1"/>
                 </a:solidFill>
-                <a:latin typeface="Cambria" pitchFamily="34" charset="0"/>
-                <a:ea typeface="Cambria" pitchFamily="34" charset="-122"/>
-                <a:cs typeface="Cambria" pitchFamily="34" charset="-120"/>
+                <a:latin typeface="Georgia" pitchFamily="34" charset="0"/>
+                <a:ea typeface="Georgia" pitchFamily="34" charset="-122"/>
+                <a:cs typeface="Georgia" pitchFamily="34" charset="-120"/>
               </a:rPr>
               <a:t>АО</a:t>
             </a:r>
@@ -14915,9 +14922,9 @@
                 <a:solidFill>
                   <a:schemeClr val="tx1"/>
                 </a:solidFill>
-                <a:latin typeface="Cambria" pitchFamily="34" charset="0"/>
-                <a:ea typeface="Cambria" pitchFamily="34" charset="-122"/>
-                <a:cs typeface="Cambria" pitchFamily="34" charset="-120"/>
+                <a:latin typeface="Georgia" pitchFamily="34" charset="0"/>
+                <a:ea typeface="Georgia" pitchFamily="34" charset="-122"/>
+                <a:cs typeface="Georgia" pitchFamily="34" charset="-120"/>
               </a:rPr>
               <a:t>Товарищества: кто рискует всем</a:t>
             </a:r>
@@ -14981,9 +14988,9 @@
                 <a:solidFill>
                   <a:schemeClr val="tx1"/>
                 </a:solidFill>
-                <a:latin typeface="Cambria" pitchFamily="34" charset="0"/>
-                <a:ea typeface="Cambria" pitchFamily="34" charset="-122"/>
-                <a:cs typeface="Cambria" pitchFamily="34" charset="-120"/>
+                <a:latin typeface="Georgia" pitchFamily="34" charset="0"/>
+                <a:ea typeface="Georgia" pitchFamily="34" charset="-122"/>
+                <a:cs typeface="Georgia" pitchFamily="34" charset="-120"/>
               </a:rPr>
               <a:t>Полное товарищество</a:t>
             </a:r>
@@ -15469,9 +15476,9 @@
                 <a:solidFill>
                   <a:schemeClr val="tx1"/>
                 </a:solidFill>
-                <a:latin typeface="Cambria" pitchFamily="34" charset="0"/>
-                <a:ea typeface="Cambria" pitchFamily="34" charset="-122"/>
-                <a:cs typeface="Cambria" pitchFamily="34" charset="-120"/>
+                <a:latin typeface="Georgia" pitchFamily="34" charset="0"/>
+                <a:ea typeface="Georgia" pitchFamily="34" charset="-122"/>
+                <a:cs typeface="Georgia" pitchFamily="34" charset="-120"/>
               </a:rPr>
               <a:t>Товарищество на вере</a:t>
             </a:r>
@@ -19238,9 +19245,9 @@
                 <a:solidFill>
                   <a:schemeClr val="tx1"/>
                 </a:solidFill>
-                <a:latin typeface="Cambria" pitchFamily="34" charset="0"/>
-                <a:ea typeface="Cambria" pitchFamily="34" charset="-122"/>
-                <a:cs typeface="Cambria" pitchFamily="34" charset="-120"/>
+                <a:latin typeface="Georgia" pitchFamily="34" charset="0"/>
+                <a:ea typeface="Georgia" pitchFamily="34" charset="-122"/>
+                <a:cs typeface="Georgia" pitchFamily="34" charset="-120"/>
               </a:rPr>
               <a:t>Производственный кооператив (артель)</a:t>
             </a:r>
@@ -19389,9 +19396,9 @@
                 <a:solidFill>
                   <a:schemeClr val="tx1"/>
                 </a:solidFill>
-                <a:latin typeface="Cambria" pitchFamily="34" charset="0"/>
-                <a:ea typeface="Cambria" pitchFamily="34" charset="-122"/>
-                <a:cs typeface="Cambria" pitchFamily="34" charset="-120"/>
+                <a:latin typeface="Georgia" pitchFamily="34" charset="0"/>
+                <a:ea typeface="Georgia" pitchFamily="34" charset="-122"/>
+                <a:cs typeface="Georgia" pitchFamily="34" charset="-120"/>
               </a:rPr>
               <a:t>5+</a:t>
             </a:r>
@@ -19513,9 +19520,9 @@
                 <a:solidFill>
                   <a:schemeClr val="tx1"/>
                 </a:solidFill>
-                <a:latin typeface="Cambria" pitchFamily="34" charset="0"/>
-                <a:ea typeface="Cambria" pitchFamily="34" charset="-122"/>
-                <a:cs typeface="Cambria" pitchFamily="34" charset="-120"/>
+                <a:latin typeface="Georgia" pitchFamily="34" charset="0"/>
+                <a:ea typeface="Georgia" pitchFamily="34" charset="-122"/>
+                <a:cs typeface="Georgia" pitchFamily="34" charset="-120"/>
               </a:rPr>
               <a:t>1 = 1</a:t>
             </a:r>
@@ -19637,9 +19644,9 @@
                 <a:solidFill>
                   <a:schemeClr val="tx1"/>
                 </a:solidFill>
-                <a:latin typeface="Cambria" pitchFamily="34" charset="0"/>
-                <a:ea typeface="Cambria" pitchFamily="34" charset="-122"/>
-                <a:cs typeface="Cambria" pitchFamily="34" charset="-120"/>
+                <a:latin typeface="Georgia" pitchFamily="34" charset="0"/>
+                <a:ea typeface="Georgia" pitchFamily="34" charset="-122"/>
+                <a:cs typeface="Georgia" pitchFamily="34" charset="-120"/>
               </a:rPr>
               <a:t>Труд</a:t>
             </a:r>
@@ -22469,9 +22476,9 @@
                 <a:solidFill>
                   <a:schemeClr val="tx1"/>
                 </a:solidFill>
-                <a:latin typeface="Cambria" pitchFamily="34" charset="0"/>
-                <a:ea typeface="Cambria" pitchFamily="34" charset="-122"/>
-                <a:cs typeface="Cambria" pitchFamily="34" charset="-120"/>
+                <a:latin typeface="Georgia" pitchFamily="34" charset="0"/>
+                <a:ea typeface="Georgia" pitchFamily="34" charset="-122"/>
+                <a:cs typeface="Georgia" pitchFamily="34" charset="-120"/>
               </a:rPr>
               <a:t>ГУП и МУП: имущество у государства</a:t>
             </a:r>
@@ -26161,9 +26168,9 @@
                 <a:solidFill>
                   <a:schemeClr val="tx1"/>
                 </a:solidFill>
-                <a:latin typeface="Cambria" pitchFamily="34" charset="0"/>
-                <a:ea typeface="Cambria" pitchFamily="34" charset="-122"/>
-                <a:cs typeface="Cambria" pitchFamily="34" charset="-120"/>
+                <a:latin typeface="Georgia" pitchFamily="34" charset="0"/>
+                <a:ea typeface="Georgia" pitchFamily="34" charset="-122"/>
+                <a:cs typeface="Georgia" pitchFamily="34" charset="-120"/>
               </a:rPr>
               <a:t>Сравним формы</a:t>
             </a:r>
@@ -26228,7 +26235,7 @@
                   <a:tcPr marL="73152" marR="73152" marT="73152" marB="73152" anchor="ctr">
                     <a:lnL w="9525" cap="flat" cmpd="sng" algn="ctr">
                       <a:solidFill>
-                        <a:srgbClr val="D9E2EC"/>
+                        <a:srgbClr val="D3E0D8"/>
                       </a:solidFill>
                       <a:prstDash val="solid"/>
                       <a:round/>
@@ -26237,7 +26244,7 @@
                     </a:lnL>
                     <a:lnR w="9525" cap="flat" cmpd="sng" algn="ctr">
                       <a:solidFill>
-                        <a:srgbClr val="D9E2EC"/>
+                        <a:srgbClr val="D3E0D8"/>
                       </a:solidFill>
                       <a:prstDash val="solid"/>
                       <a:round/>
@@ -26246,7 +26253,7 @@
                     </a:lnR>
                     <a:lnT w="9525" cap="flat" cmpd="sng" algn="ctr">
                       <a:solidFill>
-                        <a:srgbClr val="D9E2EC"/>
+                        <a:srgbClr val="D3E0D8"/>
                       </a:solidFill>
                       <a:prstDash val="solid"/>
                       <a:round/>
@@ -26255,7 +26262,7 @@
                     </a:lnT>
                     <a:lnB w="9525" cap="flat" cmpd="sng" algn="ctr">
                       <a:solidFill>
-                        <a:srgbClr val="D9E2EC"/>
+                        <a:srgbClr val="D3E0D8"/>
                       </a:solidFill>
                       <a:prstDash val="solid"/>
                       <a:round/>
@@ -26263,7 +26270,7 @@
                       <a:tailEnd type="none" w="med" len="med"/>
                     </a:lnB>
                     <a:solidFill>
-                      <a:srgbClr val="102A43"/>
+                      <a:srgbClr val="0F2E24"/>
                     </a:solidFill>
                   </a:tcPr>
                 </a:tc>
@@ -26296,7 +26303,7 @@
                   <a:tcPr marL="73152" marR="73152" marT="73152" marB="73152" anchor="ctr">
                     <a:lnL w="9525" cap="flat" cmpd="sng" algn="ctr">
                       <a:solidFill>
-                        <a:srgbClr val="D9E2EC"/>
+                        <a:srgbClr val="D3E0D8"/>
                       </a:solidFill>
                       <a:prstDash val="solid"/>
                       <a:round/>
@@ -26305,7 +26312,7 @@
                     </a:lnL>
                     <a:lnR w="9525" cap="flat" cmpd="sng" algn="ctr">
                       <a:solidFill>
-                        <a:srgbClr val="D9E2EC"/>
+                        <a:srgbClr val="D3E0D8"/>
                       </a:solidFill>
                       <a:prstDash val="solid"/>
                       <a:round/>
@@ -26314,7 +26321,7 @@
                     </a:lnR>
                     <a:lnT w="9525" cap="flat" cmpd="sng" algn="ctr">
                       <a:solidFill>
-                        <a:srgbClr val="D9E2EC"/>
+                        <a:srgbClr val="D3E0D8"/>
                       </a:solidFill>
                       <a:prstDash val="solid"/>
                       <a:round/>
@@ -26323,7 +26330,7 @@
                     </a:lnT>
                     <a:lnB w="9525" cap="flat" cmpd="sng" algn="ctr">
                       <a:solidFill>
-                        <a:srgbClr val="D9E2EC"/>
+                        <a:srgbClr val="D3E0D8"/>
                       </a:solidFill>
                       <a:prstDash val="solid"/>
                       <a:round/>
@@ -26331,7 +26338,7 @@
                       <a:tailEnd type="none" w="med" len="med"/>
                     </a:lnB>
                     <a:solidFill>
-                      <a:srgbClr val="102A43"/>
+                      <a:srgbClr val="0F2E24"/>
                     </a:solidFill>
                   </a:tcPr>
                 </a:tc>
@@ -26364,7 +26371,7 @@
                   <a:tcPr marL="73152" marR="73152" marT="73152" marB="73152" anchor="ctr">
                     <a:lnL w="9525" cap="flat" cmpd="sng" algn="ctr">
                       <a:solidFill>
-                        <a:srgbClr val="D9E2EC"/>
+                        <a:srgbClr val="D3E0D8"/>
                       </a:solidFill>
                       <a:prstDash val="solid"/>
                       <a:round/>
@@ -26373,7 +26380,7 @@
                     </a:lnL>
                     <a:lnR w="9525" cap="flat" cmpd="sng" algn="ctr">
                       <a:solidFill>
-                        <a:srgbClr val="D9E2EC"/>
+                        <a:srgbClr val="D3E0D8"/>
                       </a:solidFill>
                       <a:prstDash val="solid"/>
                       <a:round/>
@@ -26382,7 +26389,7 @@
                     </a:lnR>
                     <a:lnT w="9525" cap="flat" cmpd="sng" algn="ctr">
                       <a:solidFill>
-                        <a:srgbClr val="D9E2EC"/>
+                        <a:srgbClr val="D3E0D8"/>
                       </a:solidFill>
                       <a:prstDash val="solid"/>
                       <a:round/>
@@ -26391,7 +26398,7 @@
                     </a:lnT>
                     <a:lnB w="9525" cap="flat" cmpd="sng" algn="ctr">
                       <a:solidFill>
-                        <a:srgbClr val="D9E2EC"/>
+                        <a:srgbClr val="D3E0D8"/>
                       </a:solidFill>
                       <a:prstDash val="solid"/>
                       <a:round/>
@@ -26399,7 +26406,7 @@
                       <a:tailEnd type="none" w="med" len="med"/>
                     </a:lnB>
                     <a:solidFill>
-                      <a:srgbClr val="102A43"/>
+                      <a:srgbClr val="0F2E24"/>
                     </a:solidFill>
                   </a:tcPr>
                 </a:tc>
@@ -26416,7 +26423,7 @@
                       <a:r>
                         <a:rPr lang="ru-RU" sz="1400" dirty="0">
                           <a:solidFill>
-                            <a:srgbClr val="102A43"/>
+                            <a:srgbClr val="0F2E24"/>
                           </a:solidFill>
                           <a:latin typeface="Calibri" pitchFamily="34" charset="0"/>
                           <a:ea typeface="Calibri" pitchFamily="34" charset="-122"/>
@@ -26434,7 +26441,7 @@
                   <a:tcPr marL="73152" marR="73152" marT="73152" marB="73152" anchor="ctr">
                     <a:lnL w="9525" cap="flat" cmpd="sng" algn="ctr">
                       <a:solidFill>
-                        <a:srgbClr val="D9E2EC"/>
+                        <a:srgbClr val="D3E0D8"/>
                       </a:solidFill>
                       <a:prstDash val="solid"/>
                       <a:round/>
@@ -26443,7 +26450,7 @@
                     </a:lnL>
                     <a:lnR w="9525" cap="flat" cmpd="sng" algn="ctr">
                       <a:solidFill>
-                        <a:srgbClr val="D9E2EC"/>
+                        <a:srgbClr val="D3E0D8"/>
                       </a:solidFill>
                       <a:prstDash val="solid"/>
                       <a:round/>
@@ -26452,7 +26459,7 @@
                     </a:lnR>
                     <a:lnT w="9525" cap="flat" cmpd="sng" algn="ctr">
                       <a:solidFill>
-                        <a:srgbClr val="D9E2EC"/>
+                        <a:srgbClr val="D3E0D8"/>
                       </a:solidFill>
                       <a:prstDash val="solid"/>
                       <a:round/>
@@ -26461,7 +26468,7 @@
                     </a:lnT>
                     <a:lnB w="9525" cap="flat" cmpd="sng" algn="ctr">
                       <a:solidFill>
-                        <a:srgbClr val="D9E2EC"/>
+                        <a:srgbClr val="D3E0D8"/>
                       </a:solidFill>
                       <a:prstDash val="solid"/>
                       <a:round/>
@@ -26484,7 +26491,7 @@
                       <a:r>
                         <a:rPr lang="ru-RU" sz="1400" dirty="0">
                           <a:solidFill>
-                            <a:srgbClr val="102A43"/>
+                            <a:srgbClr val="0F2E24"/>
                           </a:solidFill>
                           <a:latin typeface="Calibri" pitchFamily="34" charset="0"/>
                           <a:ea typeface="Calibri" pitchFamily="34" charset="-122"/>
@@ -26502,7 +26509,7 @@
                   <a:tcPr marL="73152" marR="73152" marT="73152" marB="73152" anchor="ctr">
                     <a:lnL w="9525" cap="flat" cmpd="sng" algn="ctr">
                       <a:solidFill>
-                        <a:srgbClr val="D9E2EC"/>
+                        <a:srgbClr val="D3E0D8"/>
                       </a:solidFill>
                       <a:prstDash val="solid"/>
                       <a:round/>
@@ -26511,7 +26518,7 @@
                     </a:lnL>
                     <a:lnR w="9525" cap="flat" cmpd="sng" algn="ctr">
                       <a:solidFill>
-                        <a:srgbClr val="D9E2EC"/>
+                        <a:srgbClr val="D3E0D8"/>
                       </a:solidFill>
                       <a:prstDash val="solid"/>
                       <a:round/>
@@ -26520,7 +26527,7 @@
                     </a:lnR>
                     <a:lnT w="9525" cap="flat" cmpd="sng" algn="ctr">
                       <a:solidFill>
-                        <a:srgbClr val="D9E2EC"/>
+                        <a:srgbClr val="D3E0D8"/>
                       </a:solidFill>
                       <a:prstDash val="solid"/>
                       <a:round/>
@@ -26529,7 +26536,7 @@
                     </a:lnT>
                     <a:lnB w="9525" cap="flat" cmpd="sng" algn="ctr">
                       <a:solidFill>
-                        <a:srgbClr val="D9E2EC"/>
+                        <a:srgbClr val="D3E0D8"/>
                       </a:solidFill>
                       <a:prstDash val="solid"/>
                       <a:round/>
@@ -26552,7 +26559,7 @@
                       <a:r>
                         <a:rPr lang="ru-RU" sz="1400" b="1" dirty="0">
                           <a:solidFill>
-                            <a:srgbClr val="EF6C57"/>
+                            <a:srgbClr val="B23A48"/>
                           </a:solidFill>
                           <a:latin typeface="Calibri" pitchFamily="34" charset="0"/>
                           <a:ea typeface="Calibri" pitchFamily="34" charset="-122"/>
@@ -26570,7 +26577,7 @@
                   <a:tcPr marL="73152" marR="73152" marT="73152" marB="73152" anchor="ctr">
                     <a:lnL w="9525" cap="flat" cmpd="sng" algn="ctr">
                       <a:solidFill>
-                        <a:srgbClr val="D9E2EC"/>
+                        <a:srgbClr val="D3E0D8"/>
                       </a:solidFill>
                       <a:prstDash val="solid"/>
                       <a:round/>
@@ -26579,7 +26586,7 @@
                     </a:lnL>
                     <a:lnR w="9525" cap="flat" cmpd="sng" algn="ctr">
                       <a:solidFill>
-                        <a:srgbClr val="D9E2EC"/>
+                        <a:srgbClr val="D3E0D8"/>
                       </a:solidFill>
                       <a:prstDash val="solid"/>
                       <a:round/>
@@ -26588,7 +26595,7 @@
                     </a:lnR>
                     <a:lnT w="9525" cap="flat" cmpd="sng" algn="ctr">
                       <a:solidFill>
-                        <a:srgbClr val="D9E2EC"/>
+                        <a:srgbClr val="D3E0D8"/>
                       </a:solidFill>
                       <a:prstDash val="solid"/>
                       <a:round/>
@@ -26597,7 +26604,7 @@
                     </a:lnT>
                     <a:lnB w="9525" cap="flat" cmpd="sng" algn="ctr">
                       <a:solidFill>
-                        <a:srgbClr val="D9E2EC"/>
+                        <a:srgbClr val="D3E0D8"/>
                       </a:solidFill>
                       <a:prstDash val="solid"/>
                       <a:round/>
@@ -26622,7 +26629,7 @@
                       <a:r>
                         <a:rPr lang="ru-RU" sz="1400" dirty="0">
                           <a:solidFill>
-                            <a:srgbClr val="102A43"/>
+                            <a:srgbClr val="0F2E24"/>
                           </a:solidFill>
                           <a:latin typeface="Calibri" pitchFamily="34" charset="0"/>
                           <a:ea typeface="Calibri" pitchFamily="34" charset="-122"/>
@@ -26640,7 +26647,7 @@
                   <a:tcPr marL="73152" marR="73152" marT="73152" marB="73152" anchor="ctr">
                     <a:lnL w="9525" cap="flat" cmpd="sng" algn="ctr">
                       <a:solidFill>
-                        <a:srgbClr val="D9E2EC"/>
+                        <a:srgbClr val="D3E0D8"/>
                       </a:solidFill>
                       <a:prstDash val="solid"/>
                       <a:round/>
@@ -26649,7 +26656,7 @@
                     </a:lnL>
                     <a:lnR w="9525" cap="flat" cmpd="sng" algn="ctr">
                       <a:solidFill>
-                        <a:srgbClr val="D9E2EC"/>
+                        <a:srgbClr val="D3E0D8"/>
                       </a:solidFill>
                       <a:prstDash val="solid"/>
                       <a:round/>
@@ -26658,7 +26665,7 @@
                     </a:lnR>
                     <a:lnT w="9525" cap="flat" cmpd="sng" algn="ctr">
                       <a:solidFill>
-                        <a:srgbClr val="D9E2EC"/>
+                        <a:srgbClr val="D3E0D8"/>
                       </a:solidFill>
                       <a:prstDash val="solid"/>
                       <a:round/>
@@ -26667,7 +26674,7 @@
                     </a:lnT>
                     <a:lnB w="9525" cap="flat" cmpd="sng" algn="ctr">
                       <a:solidFill>
-                        <a:srgbClr val="D9E2EC"/>
+                        <a:srgbClr val="D3E0D8"/>
                       </a:solidFill>
                       <a:prstDash val="solid"/>
                       <a:round/>
@@ -26690,7 +26697,7 @@
                       <a:r>
                         <a:rPr lang="ru-RU" sz="1400" dirty="0">
                           <a:solidFill>
-                            <a:srgbClr val="102A43"/>
+                            <a:srgbClr val="0F2E24"/>
                           </a:solidFill>
                           <a:latin typeface="Calibri" pitchFamily="34" charset="0"/>
                           <a:ea typeface="Calibri" pitchFamily="34" charset="-122"/>
@@ -26708,7 +26715,7 @@
                   <a:tcPr marL="73152" marR="73152" marT="73152" marB="73152" anchor="ctr">
                     <a:lnL w="9525" cap="flat" cmpd="sng" algn="ctr">
                       <a:solidFill>
-                        <a:srgbClr val="D9E2EC"/>
+                        <a:srgbClr val="D3E0D8"/>
                       </a:solidFill>
                       <a:prstDash val="solid"/>
                       <a:round/>
@@ -26717,7 +26724,7 @@
                     </a:lnL>
                     <a:lnR w="9525" cap="flat" cmpd="sng" algn="ctr">
                       <a:solidFill>
-                        <a:srgbClr val="D9E2EC"/>
+                        <a:srgbClr val="D3E0D8"/>
                       </a:solidFill>
                       <a:prstDash val="solid"/>
                       <a:round/>
@@ -26726,7 +26733,7 @@
                     </a:lnR>
                     <a:lnT w="9525" cap="flat" cmpd="sng" algn="ctr">
                       <a:solidFill>
-                        <a:srgbClr val="D9E2EC"/>
+                        <a:srgbClr val="D3E0D8"/>
                       </a:solidFill>
                       <a:prstDash val="solid"/>
                       <a:round/>
@@ -26735,7 +26742,7 @@
                     </a:lnT>
                     <a:lnB w="9525" cap="flat" cmpd="sng" algn="ctr">
                       <a:solidFill>
-                        <a:srgbClr val="D9E2EC"/>
+                        <a:srgbClr val="D3E0D8"/>
                       </a:solidFill>
                       <a:prstDash val="solid"/>
                       <a:round/>
@@ -26758,7 +26765,7 @@
                       <a:r>
                         <a:rPr lang="ru-RU" sz="1400" b="1" dirty="0">
                           <a:solidFill>
-                            <a:srgbClr val="1F8A80"/>
+                            <a:srgbClr val="1E7B4F"/>
                           </a:solidFill>
                           <a:latin typeface="Calibri" pitchFamily="34" charset="0"/>
                           <a:ea typeface="Calibri" pitchFamily="34" charset="-122"/>
@@ -26776,7 +26783,7 @@
                   <a:tcPr marL="73152" marR="73152" marT="73152" marB="73152" anchor="ctr">
                     <a:lnL w="9525" cap="flat" cmpd="sng" algn="ctr">
                       <a:solidFill>
-                        <a:srgbClr val="D9E2EC"/>
+                        <a:srgbClr val="D3E0D8"/>
                       </a:solidFill>
                       <a:prstDash val="solid"/>
                       <a:round/>
@@ -26785,7 +26792,7 @@
                     </a:lnL>
                     <a:lnR w="9525" cap="flat" cmpd="sng" algn="ctr">
                       <a:solidFill>
-                        <a:srgbClr val="D9E2EC"/>
+                        <a:srgbClr val="D3E0D8"/>
                       </a:solidFill>
                       <a:prstDash val="solid"/>
                       <a:round/>
@@ -26794,7 +26801,7 @@
                     </a:lnR>
                     <a:lnT w="9525" cap="flat" cmpd="sng" algn="ctr">
                       <a:solidFill>
-                        <a:srgbClr val="D9E2EC"/>
+                        <a:srgbClr val="D3E0D8"/>
                       </a:solidFill>
                       <a:prstDash val="solid"/>
                       <a:round/>
@@ -26803,7 +26810,7 @@
                     </a:lnT>
                     <a:lnB w="9525" cap="flat" cmpd="sng" algn="ctr">
                       <a:solidFill>
-                        <a:srgbClr val="D9E2EC"/>
+                        <a:srgbClr val="D3E0D8"/>
                       </a:solidFill>
                       <a:prstDash val="solid"/>
                       <a:round/>
@@ -26828,7 +26835,7 @@
                       <a:r>
                         <a:rPr lang="ru-RU" sz="1400" dirty="0">
                           <a:solidFill>
-                            <a:srgbClr val="102A43"/>
+                            <a:srgbClr val="0F2E24"/>
                           </a:solidFill>
                           <a:latin typeface="Calibri" pitchFamily="34" charset="0"/>
                           <a:ea typeface="Calibri" pitchFamily="34" charset="-122"/>
@@ -26846,7 +26853,7 @@
                   <a:tcPr marL="73152" marR="73152" marT="73152" marB="73152" anchor="ctr">
                     <a:lnL w="9525" cap="flat" cmpd="sng" algn="ctr">
                       <a:solidFill>
-                        <a:srgbClr val="D9E2EC"/>
+                        <a:srgbClr val="D3E0D8"/>
                       </a:solidFill>
                       <a:prstDash val="solid"/>
                       <a:round/>
@@ -26855,7 +26862,7 @@
                     </a:lnL>
                     <a:lnR w="9525" cap="flat" cmpd="sng" algn="ctr">
                       <a:solidFill>
-                        <a:srgbClr val="D9E2EC"/>
+                        <a:srgbClr val="D3E0D8"/>
                       </a:solidFill>
                       <a:prstDash val="solid"/>
                       <a:round/>
@@ -26864,7 +26871,7 @@
                     </a:lnR>
                     <a:lnT w="9525" cap="flat" cmpd="sng" algn="ctr">
                       <a:solidFill>
-                        <a:srgbClr val="D9E2EC"/>
+                        <a:srgbClr val="D3E0D8"/>
                       </a:solidFill>
                       <a:prstDash val="solid"/>
                       <a:round/>
@@ -26873,7 +26880,7 @@
                     </a:lnT>
                     <a:lnB w="9525" cap="flat" cmpd="sng" algn="ctr">
                       <a:solidFill>
-                        <a:srgbClr val="D9E2EC"/>
+                        <a:srgbClr val="D3E0D8"/>
                       </a:solidFill>
                       <a:prstDash val="solid"/>
                       <a:round/>
@@ -26896,7 +26903,7 @@
                       <a:r>
                         <a:rPr lang="ru-RU" sz="1400" dirty="0">
                           <a:solidFill>
-                            <a:srgbClr val="102A43"/>
+                            <a:srgbClr val="0F2E24"/>
                           </a:solidFill>
                           <a:latin typeface="Calibri" pitchFamily="34" charset="0"/>
                           <a:ea typeface="Calibri" pitchFamily="34" charset="-122"/>
@@ -26914,7 +26921,7 @@
                   <a:tcPr marL="73152" marR="73152" marT="73152" marB="73152" anchor="ctr">
                     <a:lnL w="9525" cap="flat" cmpd="sng" algn="ctr">
                       <a:solidFill>
-                        <a:srgbClr val="D9E2EC"/>
+                        <a:srgbClr val="D3E0D8"/>
                       </a:solidFill>
                       <a:prstDash val="solid"/>
                       <a:round/>
@@ -26923,7 +26930,7 @@
                     </a:lnL>
                     <a:lnR w="9525" cap="flat" cmpd="sng" algn="ctr">
                       <a:solidFill>
-                        <a:srgbClr val="D9E2EC"/>
+                        <a:srgbClr val="D3E0D8"/>
                       </a:solidFill>
                       <a:prstDash val="solid"/>
                       <a:round/>
@@ -26932,7 +26939,7 @@
                     </a:lnR>
                     <a:lnT w="9525" cap="flat" cmpd="sng" algn="ctr">
                       <a:solidFill>
-                        <a:srgbClr val="D9E2EC"/>
+                        <a:srgbClr val="D3E0D8"/>
                       </a:solidFill>
                       <a:prstDash val="solid"/>
                       <a:round/>
@@ -26941,7 +26948,7 @@
                     </a:lnT>
                     <a:lnB w="9525" cap="flat" cmpd="sng" algn="ctr">
                       <a:solidFill>
-                        <a:srgbClr val="D9E2EC"/>
+                        <a:srgbClr val="D3E0D8"/>
                       </a:solidFill>
                       <a:prstDash val="solid"/>
                       <a:round/>
@@ -26964,7 +26971,7 @@
                       <a:r>
                         <a:rPr lang="ru-RU" sz="1400" b="1" dirty="0">
                           <a:solidFill>
-                            <a:srgbClr val="1F8A80"/>
+                            <a:srgbClr val="1E7B4F"/>
                           </a:solidFill>
                           <a:latin typeface="Calibri" pitchFamily="34" charset="0"/>
                           <a:ea typeface="Calibri" pitchFamily="34" charset="-122"/>
@@ -26982,7 +26989,7 @@
                   <a:tcPr marL="73152" marR="73152" marT="73152" marB="73152" anchor="ctr">
                     <a:lnL w="9525" cap="flat" cmpd="sng" algn="ctr">
                       <a:solidFill>
-                        <a:srgbClr val="D9E2EC"/>
+                        <a:srgbClr val="D3E0D8"/>
                       </a:solidFill>
                       <a:prstDash val="solid"/>
                       <a:round/>
@@ -26991,7 +26998,7 @@
                     </a:lnL>
                     <a:lnR w="9525" cap="flat" cmpd="sng" algn="ctr">
                       <a:solidFill>
-                        <a:srgbClr val="D9E2EC"/>
+                        <a:srgbClr val="D3E0D8"/>
                       </a:solidFill>
                       <a:prstDash val="solid"/>
                       <a:round/>
@@ -27000,7 +27007,7 @@
                     </a:lnR>
                     <a:lnT w="9525" cap="flat" cmpd="sng" algn="ctr">
                       <a:solidFill>
-                        <a:srgbClr val="D9E2EC"/>
+                        <a:srgbClr val="D3E0D8"/>
                       </a:solidFill>
                       <a:prstDash val="solid"/>
                       <a:round/>
@@ -27009,7 +27016,7 @@
                     </a:lnT>
                     <a:lnB w="9525" cap="flat" cmpd="sng" algn="ctr">
                       <a:solidFill>
-                        <a:srgbClr val="D9E2EC"/>
+                        <a:srgbClr val="D3E0D8"/>
                       </a:solidFill>
                       <a:prstDash val="solid"/>
                       <a:round/>
@@ -27034,7 +27041,7 @@
                       <a:r>
                         <a:rPr lang="ru-RU" sz="1400" dirty="0">
                           <a:solidFill>
-                            <a:srgbClr val="102A43"/>
+                            <a:srgbClr val="0F2E24"/>
                           </a:solidFill>
                           <a:latin typeface="Calibri" pitchFamily="34" charset="0"/>
                           <a:ea typeface="Calibri" pitchFamily="34" charset="-122"/>
@@ -27052,7 +27059,7 @@
                   <a:tcPr marL="73152" marR="73152" marT="73152" marB="73152" anchor="ctr">
                     <a:lnL w="9525" cap="flat" cmpd="sng" algn="ctr">
                       <a:solidFill>
-                        <a:srgbClr val="D9E2EC"/>
+                        <a:srgbClr val="D3E0D8"/>
                       </a:solidFill>
                       <a:prstDash val="solid"/>
                       <a:round/>
@@ -27061,7 +27068,7 @@
                     </a:lnL>
                     <a:lnR w="9525" cap="flat" cmpd="sng" algn="ctr">
                       <a:solidFill>
-                        <a:srgbClr val="D9E2EC"/>
+                        <a:srgbClr val="D3E0D8"/>
                       </a:solidFill>
                       <a:prstDash val="solid"/>
                       <a:round/>
@@ -27070,7 +27077,7 @@
                     </a:lnR>
                     <a:lnT w="9525" cap="flat" cmpd="sng" algn="ctr">
                       <a:solidFill>
-                        <a:srgbClr val="D9E2EC"/>
+                        <a:srgbClr val="D3E0D8"/>
                       </a:solidFill>
                       <a:prstDash val="solid"/>
                       <a:round/>
@@ -27079,7 +27086,7 @@
                     </a:lnT>
                     <a:lnB w="9525" cap="flat" cmpd="sng" algn="ctr">
                       <a:solidFill>
-                        <a:srgbClr val="D9E2EC"/>
+                        <a:srgbClr val="D3E0D8"/>
                       </a:solidFill>
                       <a:prstDash val="solid"/>
                       <a:round/>
@@ -27102,7 +27109,7 @@
                       <a:r>
                         <a:rPr lang="ru-RU" sz="1400" dirty="0">
                           <a:solidFill>
-                            <a:srgbClr val="102A43"/>
+                            <a:srgbClr val="0F2E24"/>
                           </a:solidFill>
                           <a:latin typeface="Calibri" pitchFamily="34" charset="0"/>
                           <a:ea typeface="Calibri" pitchFamily="34" charset="-122"/>
@@ -27120,7 +27127,7 @@
                   <a:tcPr marL="73152" marR="73152" marT="73152" marB="73152" anchor="ctr">
                     <a:lnL w="9525" cap="flat" cmpd="sng" algn="ctr">
                       <a:solidFill>
-                        <a:srgbClr val="D9E2EC"/>
+                        <a:srgbClr val="D3E0D8"/>
                       </a:solidFill>
                       <a:prstDash val="solid"/>
                       <a:round/>
@@ -27129,7 +27136,7 @@
                     </a:lnL>
                     <a:lnR w="9525" cap="flat" cmpd="sng" algn="ctr">
                       <a:solidFill>
-                        <a:srgbClr val="D9E2EC"/>
+                        <a:srgbClr val="D3E0D8"/>
                       </a:solidFill>
                       <a:prstDash val="solid"/>
                       <a:round/>
@@ -27138,7 +27145,7 @@
                     </a:lnR>
                     <a:lnT w="9525" cap="flat" cmpd="sng" algn="ctr">
                       <a:solidFill>
-                        <a:srgbClr val="D9E2EC"/>
+                        <a:srgbClr val="D3E0D8"/>
                       </a:solidFill>
                       <a:prstDash val="solid"/>
                       <a:round/>
@@ -27147,7 +27154,7 @@
                     </a:lnT>
                     <a:lnB w="9525" cap="flat" cmpd="sng" algn="ctr">
                       <a:solidFill>
-                        <a:srgbClr val="D9E2EC"/>
+                        <a:srgbClr val="D3E0D8"/>
                       </a:solidFill>
                       <a:prstDash val="solid"/>
                       <a:round/>
@@ -27170,7 +27177,7 @@
                       <a:r>
                         <a:rPr lang="ru-RU" sz="1400" b="1" dirty="0">
                           <a:solidFill>
-                            <a:srgbClr val="EF6C57"/>
+                            <a:srgbClr val="B23A48"/>
                           </a:solidFill>
                           <a:latin typeface="Calibri" pitchFamily="34" charset="0"/>
                           <a:ea typeface="Calibri" pitchFamily="34" charset="-122"/>
@@ -27188,7 +27195,7 @@
                   <a:tcPr marL="73152" marR="73152" marT="73152" marB="73152" anchor="ctr">
                     <a:lnL w="9525" cap="flat" cmpd="sng" algn="ctr">
                       <a:solidFill>
-                        <a:srgbClr val="D9E2EC"/>
+                        <a:srgbClr val="D3E0D8"/>
                       </a:solidFill>
                       <a:prstDash val="solid"/>
                       <a:round/>
@@ -27197,7 +27204,7 @@
                     </a:lnL>
                     <a:lnR w="9525" cap="flat" cmpd="sng" algn="ctr">
                       <a:solidFill>
-                        <a:srgbClr val="D9E2EC"/>
+                        <a:srgbClr val="D3E0D8"/>
                       </a:solidFill>
                       <a:prstDash val="solid"/>
                       <a:round/>
@@ -27206,7 +27213,7 @@
                     </a:lnR>
                     <a:lnT w="9525" cap="flat" cmpd="sng" algn="ctr">
                       <a:solidFill>
-                        <a:srgbClr val="D9E2EC"/>
+                        <a:srgbClr val="D3E0D8"/>
                       </a:solidFill>
                       <a:prstDash val="solid"/>
                       <a:round/>
@@ -27215,7 +27222,7 @@
                     </a:lnT>
                     <a:lnB w="9525" cap="flat" cmpd="sng" algn="ctr">
                       <a:solidFill>
-                        <a:srgbClr val="D9E2EC"/>
+                        <a:srgbClr val="D3E0D8"/>
                       </a:solidFill>
                       <a:prstDash val="solid"/>
                       <a:round/>
@@ -27240,7 +27247,7 @@
                       <a:r>
                         <a:rPr lang="ru-RU" sz="1400" dirty="0">
                           <a:solidFill>
-                            <a:srgbClr val="102A43"/>
+                            <a:srgbClr val="0F2E24"/>
                           </a:solidFill>
                           <a:latin typeface="Calibri" pitchFamily="34" charset="0"/>
                           <a:ea typeface="Calibri" pitchFamily="34" charset="-122"/>
@@ -27258,7 +27265,7 @@
                   <a:tcPr marL="73152" marR="73152" marT="73152" marB="73152" anchor="ctr">
                     <a:lnL w="9525" cap="flat" cmpd="sng" algn="ctr">
                       <a:solidFill>
-                        <a:srgbClr val="D9E2EC"/>
+                        <a:srgbClr val="D3E0D8"/>
                       </a:solidFill>
                       <a:prstDash val="solid"/>
                       <a:round/>
@@ -27267,7 +27274,7 @@
                     </a:lnL>
                     <a:lnR w="9525" cap="flat" cmpd="sng" algn="ctr">
                       <a:solidFill>
-                        <a:srgbClr val="D9E2EC"/>
+                        <a:srgbClr val="D3E0D8"/>
                       </a:solidFill>
                       <a:prstDash val="solid"/>
                       <a:round/>
@@ -27276,7 +27283,7 @@
                     </a:lnR>
                     <a:lnT w="9525" cap="flat" cmpd="sng" algn="ctr">
                       <a:solidFill>
-                        <a:srgbClr val="D9E2EC"/>
+                        <a:srgbClr val="D3E0D8"/>
                       </a:solidFill>
                       <a:prstDash val="solid"/>
                       <a:round/>
@@ -27285,7 +27292,7 @@
                     </a:lnT>
                     <a:lnB w="9525" cap="flat" cmpd="sng" algn="ctr">
                       <a:solidFill>
-                        <a:srgbClr val="D9E2EC"/>
+                        <a:srgbClr val="D3E0D8"/>
                       </a:solidFill>
                       <a:prstDash val="solid"/>
                       <a:round/>
@@ -27308,7 +27315,7 @@
                       <a:r>
                         <a:rPr lang="ru-RU" sz="1400" dirty="0">
                           <a:solidFill>
-                            <a:srgbClr val="102A43"/>
+                            <a:srgbClr val="0F2E24"/>
                           </a:solidFill>
                           <a:latin typeface="Calibri" pitchFamily="34" charset="0"/>
                           <a:ea typeface="Calibri" pitchFamily="34" charset="-122"/>
@@ -27326,7 +27333,7 @@
                   <a:tcPr marL="73152" marR="73152" marT="73152" marB="73152" anchor="ctr">
                     <a:lnL w="9525" cap="flat" cmpd="sng" algn="ctr">
                       <a:solidFill>
-                        <a:srgbClr val="D9E2EC"/>
+                        <a:srgbClr val="D3E0D8"/>
                       </a:solidFill>
                       <a:prstDash val="solid"/>
                       <a:round/>
@@ -27335,7 +27342,7 @@
                     </a:lnL>
                     <a:lnR w="9525" cap="flat" cmpd="sng" algn="ctr">
                       <a:solidFill>
-                        <a:srgbClr val="D9E2EC"/>
+                        <a:srgbClr val="D3E0D8"/>
                       </a:solidFill>
                       <a:prstDash val="solid"/>
                       <a:round/>
@@ -27344,7 +27351,7 @@
                     </a:lnR>
                     <a:lnT w="9525" cap="flat" cmpd="sng" algn="ctr">
                       <a:solidFill>
-                        <a:srgbClr val="D9E2EC"/>
+                        <a:srgbClr val="D3E0D8"/>
                       </a:solidFill>
                       <a:prstDash val="solid"/>
                       <a:round/>
@@ -27353,7 +27360,7 @@
                     </a:lnT>
                     <a:lnB w="9525" cap="flat" cmpd="sng" algn="ctr">
                       <a:solidFill>
-                        <a:srgbClr val="D9E2EC"/>
+                        <a:srgbClr val="D3E0D8"/>
                       </a:solidFill>
                       <a:prstDash val="solid"/>
                       <a:round/>
@@ -27376,7 +27383,7 @@
                       <a:r>
                         <a:rPr lang="ru-RU" sz="1400" dirty="0">
                           <a:solidFill>
-                            <a:srgbClr val="102A43"/>
+                            <a:srgbClr val="0F2E24"/>
                           </a:solidFill>
                           <a:latin typeface="Calibri" pitchFamily="34" charset="0"/>
                           <a:ea typeface="Calibri" pitchFamily="34" charset="-122"/>
@@ -27394,7 +27401,7 @@
                   <a:tcPr marL="73152" marR="73152" marT="73152" marB="73152" anchor="ctr">
                     <a:lnL w="9525" cap="flat" cmpd="sng" algn="ctr">
                       <a:solidFill>
-                        <a:srgbClr val="D9E2EC"/>
+                        <a:srgbClr val="D3E0D8"/>
                       </a:solidFill>
                       <a:prstDash val="solid"/>
                       <a:round/>
@@ -27403,7 +27410,7 @@
                     </a:lnL>
                     <a:lnR w="9525" cap="flat" cmpd="sng" algn="ctr">
                       <a:solidFill>
-                        <a:srgbClr val="D9E2EC"/>
+                        <a:srgbClr val="D3E0D8"/>
                       </a:solidFill>
                       <a:prstDash val="solid"/>
                       <a:round/>
@@ -27412,7 +27419,7 @@
                     </a:lnR>
                     <a:lnT w="9525" cap="flat" cmpd="sng" algn="ctr">
                       <a:solidFill>
-                        <a:srgbClr val="D9E2EC"/>
+                        <a:srgbClr val="D3E0D8"/>
                       </a:solidFill>
                       <a:prstDash val="solid"/>
                       <a:round/>
@@ -27421,7 +27428,7 @@
                     </a:lnT>
                     <a:lnB w="9525" cap="flat" cmpd="sng" algn="ctr">
                       <a:solidFill>
-                        <a:srgbClr val="D9E2EC"/>
+                        <a:srgbClr val="D3E0D8"/>
                       </a:solidFill>
                       <a:prstDash val="solid"/>
                       <a:round/>
@@ -27446,7 +27453,7 @@
                       <a:r>
                         <a:rPr lang="ru-RU" sz="1400" dirty="0">
                           <a:solidFill>
-                            <a:srgbClr val="102A43"/>
+                            <a:srgbClr val="0F2E24"/>
                           </a:solidFill>
                           <a:latin typeface="Calibri" pitchFamily="34" charset="0"/>
                           <a:ea typeface="Calibri" pitchFamily="34" charset="-122"/>
@@ -27464,7 +27471,7 @@
                   <a:tcPr marL="73152" marR="73152" marT="73152" marB="73152" anchor="ctr">
                     <a:lnL w="9525" cap="flat" cmpd="sng" algn="ctr">
                       <a:solidFill>
-                        <a:srgbClr val="D9E2EC"/>
+                        <a:srgbClr val="D3E0D8"/>
                       </a:solidFill>
                       <a:prstDash val="solid"/>
                       <a:round/>
@@ -27473,7 +27480,7 @@
                     </a:lnL>
                     <a:lnR w="9525" cap="flat" cmpd="sng" algn="ctr">
                       <a:solidFill>
-                        <a:srgbClr val="D9E2EC"/>
+                        <a:srgbClr val="D3E0D8"/>
                       </a:solidFill>
                       <a:prstDash val="solid"/>
                       <a:round/>
@@ -27482,7 +27489,7 @@
                     </a:lnR>
                     <a:lnT w="9525" cap="flat" cmpd="sng" algn="ctr">
                       <a:solidFill>
-                        <a:srgbClr val="D9E2EC"/>
+                        <a:srgbClr val="D3E0D8"/>
                       </a:solidFill>
                       <a:prstDash val="solid"/>
                       <a:round/>
@@ -27491,7 +27498,7 @@
                     </a:lnT>
                     <a:lnB w="9525" cap="flat" cmpd="sng" algn="ctr">
                       <a:solidFill>
-                        <a:srgbClr val="D9E2EC"/>
+                        <a:srgbClr val="D3E0D8"/>
                       </a:solidFill>
                       <a:prstDash val="solid"/>
                       <a:round/>
@@ -27514,7 +27521,7 @@
                       <a:r>
                         <a:rPr lang="ru-RU" sz="1400" dirty="0">
                           <a:solidFill>
-                            <a:srgbClr val="102A43"/>
+                            <a:srgbClr val="0F2E24"/>
                           </a:solidFill>
                           <a:latin typeface="Calibri" pitchFamily="34" charset="0"/>
                           <a:ea typeface="Calibri" pitchFamily="34" charset="-122"/>
@@ -27532,7 +27539,7 @@
                   <a:tcPr marL="73152" marR="73152" marT="73152" marB="73152" anchor="ctr">
                     <a:lnL w="9525" cap="flat" cmpd="sng" algn="ctr">
                       <a:solidFill>
-                        <a:srgbClr val="D9E2EC"/>
+                        <a:srgbClr val="D3E0D8"/>
                       </a:solidFill>
                       <a:prstDash val="solid"/>
                       <a:round/>
@@ -27541,7 +27548,7 @@
                     </a:lnL>
                     <a:lnR w="9525" cap="flat" cmpd="sng" algn="ctr">
                       <a:solidFill>
-                        <a:srgbClr val="D9E2EC"/>
+                        <a:srgbClr val="D3E0D8"/>
                       </a:solidFill>
                       <a:prstDash val="solid"/>
                       <a:round/>
@@ -27550,7 +27557,7 @@
                     </a:lnR>
                     <a:lnT w="9525" cap="flat" cmpd="sng" algn="ctr">
                       <a:solidFill>
-                        <a:srgbClr val="D9E2EC"/>
+                        <a:srgbClr val="D3E0D8"/>
                       </a:solidFill>
                       <a:prstDash val="solid"/>
                       <a:round/>
@@ -27559,7 +27566,7 @@
                     </a:lnT>
                     <a:lnB w="9525" cap="flat" cmpd="sng" algn="ctr">
                       <a:solidFill>
-                        <a:srgbClr val="D9E2EC"/>
+                        <a:srgbClr val="D3E0D8"/>
                       </a:solidFill>
                       <a:prstDash val="solid"/>
                       <a:round/>
@@ -27582,7 +27589,7 @@
                       <a:r>
                         <a:rPr lang="ru-RU" sz="1400" dirty="0">
                           <a:solidFill>
-                            <a:srgbClr val="102A43"/>
+                            <a:srgbClr val="0F2E24"/>
                           </a:solidFill>
                           <a:latin typeface="Calibri" pitchFamily="34" charset="0"/>
                           <a:ea typeface="Calibri" pitchFamily="34" charset="-122"/>
@@ -27600,7 +27607,7 @@
                   <a:tcPr marL="73152" marR="73152" marT="73152" marB="73152" anchor="ctr">
                     <a:lnL w="9525" cap="flat" cmpd="sng" algn="ctr">
                       <a:solidFill>
-                        <a:srgbClr val="D9E2EC"/>
+                        <a:srgbClr val="D3E0D8"/>
                       </a:solidFill>
                       <a:prstDash val="solid"/>
                       <a:round/>
@@ -27609,7 +27616,7 @@
                     </a:lnL>
                     <a:lnR w="9525" cap="flat" cmpd="sng" algn="ctr">
                       <a:solidFill>
-                        <a:srgbClr val="D9E2EC"/>
+                        <a:srgbClr val="D3E0D8"/>
                       </a:solidFill>
                       <a:prstDash val="solid"/>
                       <a:round/>
@@ -27618,7 +27625,7 @@
                     </a:lnR>
                     <a:lnT w="9525" cap="flat" cmpd="sng" algn="ctr">
                       <a:solidFill>
-                        <a:srgbClr val="D9E2EC"/>
+                        <a:srgbClr val="D3E0D8"/>
                       </a:solidFill>
                       <a:prstDash val="solid"/>
                       <a:round/>
@@ -27627,7 +27634,7 @@
                     </a:lnT>
                     <a:lnB w="9525" cap="flat" cmpd="sng" algn="ctr">
                       <a:solidFill>
-                        <a:srgbClr val="D9E2EC"/>
+                        <a:srgbClr val="D3E0D8"/>
                       </a:solidFill>
                       <a:prstDash val="solid"/>
                       <a:round/>
@@ -28117,9 +28124,9 @@
                 <a:solidFill>
                   <a:schemeClr val="tx1"/>
                 </a:solidFill>
-                <a:latin typeface="Cambria" pitchFamily="34" charset="0"/>
-                <a:ea typeface="Cambria" pitchFamily="34" charset="-122"/>
-                <a:cs typeface="Cambria" pitchFamily="34" charset="-120"/>
+                <a:latin typeface="Georgia" pitchFamily="34" charset="0"/>
+                <a:ea typeface="Georgia" pitchFamily="34" charset="-122"/>
+                <a:cs typeface="Georgia" pitchFamily="34" charset="-120"/>
               </a:rPr>
               <a:t>Спасибо за внимание!</a:t>
             </a:r>
@@ -29771,49 +29778,49 @@
 </file>
 
 <file path=ppt/theme/theme1.xml><?xml version="1.0" encoding="utf-8"?>
-<a:theme xmlns:a="http://schemas.openxmlformats.org/drawingml/2006/main" name="Бизнес">
+<a:theme xmlns:a="http://schemas.openxmlformats.org/drawingml/2006/main" name="Экономика">
   <a:themeElements>
-    <a:clrScheme name="Бизнес">
+    <a:clrScheme name="Экономика">
       <a:dk1>
-        <a:srgbClr val="102A43"/>
+        <a:srgbClr val="0F2E24"/>
       </a:dk1>
       <a:lt1>
         <a:srgbClr val="FFFFFF"/>
       </a:lt1>
       <a:dk2>
-        <a:srgbClr val="486581"/>
+        <a:srgbClr val="4D6B5F"/>
       </a:dk2>
       <a:lt2>
-        <a:srgbClr val="F0F4F8"/>
+        <a:srgbClr val="EEF4F0"/>
       </a:lt2>
       <a:accent1>
-        <a:srgbClr val="2BB0A6"/>
+        <a:srgbClr val="1E7B4F"/>
       </a:accent1>
       <a:accent2>
-        <a:srgbClr val="4C8BF5"/>
+        <a:srgbClr val="2F6690"/>
       </a:accent2>
       <a:accent3>
-        <a:srgbClr val="F0B429"/>
+        <a:srgbClr val="C9A227"/>
       </a:accent3>
       <a:accent4>
-        <a:srgbClr val="EF6C57"/>
+        <a:srgbClr val="B23A48"/>
       </a:accent4>
       <a:accent5>
-        <a:srgbClr val="8E7CC3"/>
+        <a:srgbClr val="6B8F71"/>
       </a:accent5>
       <a:accent6>
-        <a:srgbClr val="D9E2EC"/>
+        <a:srgbClr val="D3E0D8"/>
       </a:accent6>
       <a:hlink>
-        <a:srgbClr val="4C8BF5"/>
+        <a:srgbClr val="2F6690"/>
       </a:hlink>
       <a:folHlink>
-        <a:srgbClr val="8E7CC3"/>
+        <a:srgbClr val="6B8F71"/>
       </a:folHlink>
     </a:clrScheme>
-    <a:fontScheme name="Бизнес">
+    <a:fontScheme name="Экономика">
       <a:majorFont>
-        <a:latin typeface="Cambria"/>
+        <a:latin typeface="Georgia"/>
         <a:ea typeface=""/>
         <a:cs typeface=""/>
         <a:font script="Jpan" typeface="游ゴシック Light"/>
@@ -29865,7 +29872,7 @@
         <a:font script="Tfng" typeface="Ebrima"/>
       </a:majorFont>
       <a:minorFont>
-        <a:latin typeface="Calibri"/>
+        <a:latin typeface="Arial"/>
         <a:ea typeface=""/>
         <a:cs typeface=""/>
         <a:font script="Jpan" typeface="游ゴシック"/>

</xml_diff>